<commit_message>
remove speaker note from pptx
</commit_message>
<xml_diff>
--- a/3일차_1강_.pptx
+++ b/3일차_1강_.pptx
@@ -380,24 +380,12 @@
             <a:noAutofit/>
           </a:bodyPr>
           <a:lstStyle/>
-          <a:p>
-            <a:r>
-              <a:t>안녕하십니까, 오늘 생성형 AI 보안취약점 분석 교육을 맡게 된 김설기입니다.</a:t>
-            </a:r>
-          </a:p>
+          <a:p/>
           <a:p>
             <a:endParaRPr/>
           </a:p>
-          <a:p>
-            <a:r>
-              <a:t>오늘 하루 동안 '보안이 없으면, AI도 없습니다'라는 명제를 함께 검증해 보겠습니다.</a:t>
-            </a:r>
-          </a:p>
-          <a:p>
-            <a:r>
-              <a:t>강의 3개, 실습 3개를 통해 AI 보안 위협을 이해하고, 직접 공격하고, 방어하는 과정을 체험합니다.</a:t>
-            </a:r>
-          </a:p>
+          <a:p/>
+          <a:p/>
         </p:txBody>
       </p:sp>
     </p:spTree>
@@ -451,24 +439,12 @@
         <p:txBody>
           <a:bodyPr/>
           <a:lstStyle/>
-          <a:p>
-            <a:r>
-              <a:t>이제 본론으로 넘어갑니다.</a:t>
-            </a:r>
-          </a:p>
+          <a:p/>
           <a:p>
             <a:endParaRPr/>
           </a:p>
-          <a:p>
-            <a:r>
-              <a:t>Clearview AI 사례는 T07 민감정보 유출, DNA 복원 사례는 T02 비인가 학습과 T04 데이터 추출에 해당합니다.</a:t>
-            </a:r>
-          </a:p>
-          <a:p>
-            <a:r>
-              <a:t>공개 조각 + AI 추론 = 비공개 정보라는 원리가 AI 시스템 전체에 걸쳐 어떻게 위협이 되는지, 지금부터 NIS 분류체계로 체계적으로 살펴보겠습니다.</a:t>
-            </a:r>
-          </a:p>
+          <a:p/>
+          <a:p/>
         </p:txBody>
       </p:sp>
       <p:sp>
@@ -550,42 +526,18 @@
         <p:txBody>
           <a:bodyPr/>
           <a:lstStyle/>
-          <a:p>
-            <a:r>
-              <a:t>숫자 세 가지만 기억해 주십시오.</a:t>
-            </a:r>
-          </a:p>
+          <a:p/>
           <a:p>
             <a:endParaRPr/>
           </a:p>
-          <a:p>
-            <a:r>
-              <a:t>4.88 밀리언 달러. 데이터 침해 1건당 평균 비용입니다. IBM 2024년 보고서 기준 역대 최고입니다.</a:t>
-            </a:r>
-          </a:p>
-          <a:p>
-            <a:r>
-              <a:t>77퍼센트. AI 시스템에 침해를 경험한 기업 비율입니다.</a:t>
-            </a:r>
-          </a:p>
-          <a:p>
-            <a:r>
-              <a:t>24퍼센트. 현재 생성형 AI 중 보안이 확보된 비율입니다.</a:t>
-            </a:r>
-          </a:p>
+          <a:p/>
+          <a:p/>
+          <a:p/>
           <a:p>
             <a:endParaRPr/>
           </a:p>
-          <a:p>
-            <a:r>
-              <a:t>다시 말하면 — AI를 도입한 조직의 76%는 보안 없이 운영 중입니다.</a:t>
-            </a:r>
-          </a:p>
-          <a:p>
-            <a:r>
-              <a:t>이 자리에 계신 분들이 이 76%에 속하지 않도록 하는 것이 오늘의 목표입니다.</a:t>
-            </a:r>
-          </a:p>
+          <a:p/>
+          <a:p/>
         </p:txBody>
       </p:sp>
       <p:sp>
@@ -667,42 +619,18 @@
         <p:txBody>
           <a:bodyPr/>
           <a:lstStyle/>
-          <a:p>
-            <a:r>
-              <a:t>더 무서운 건 속도입니다.</a:t>
-            </a:r>
-          </a:p>
+          <a:p/>
           <a:p>
             <a:endParaRPr/>
           </a:p>
-          <a:p>
-            <a:r>
-              <a:t>72분. 가장 빠른 침해의 데이터 유출 시간입니다. 작년에는 285분이었습니다. 75% 단축됐습니다.</a:t>
-            </a:r>
-          </a:p>
-          <a:p>
-            <a:r>
-              <a:t>88%. 특정 LLM 모델에 대한 공격 성공률입니다.</a:t>
-            </a:r>
-          </a:p>
-          <a:p>
-            <a:r>
-              <a:t>80% 이상. AI를 사용해서 만든 피싱 이메일 비율입니다.</a:t>
-            </a:r>
-          </a:p>
+          <a:p/>
+          <a:p/>
+          <a:p/>
           <a:p>
             <a:endParaRPr/>
           </a:p>
-          <a:p>
-            <a:r>
-              <a:t>Gartner 예측으로는 2027년까지 AI 데이터 침해의 40%가 생성형 AI 오용에서 발생합니다.</a:t>
-            </a:r>
-          </a:p>
-          <a:p>
-            <a:r>
-              <a:t>이건 미래 이야기가 아니라 지금 일어나고 있는 일입니다.</a:t>
-            </a:r>
-          </a:p>
+          <a:p/>
+          <a:p/>
         </p:txBody>
       </p:sp>
       <p:sp>
@@ -784,16 +712,8 @@
         <p:txBody>
           <a:bodyPr/>
           <a:lstStyle/>
-          <a:p>
-            <a:r>
-              <a:t>Part 1입니다. 본격적인 위협 분석에 앞서 LLM, RAG, Agent를 보안 관점에서 빠르게 복습합니다.</a:t>
-            </a:r>
-          </a:p>
-          <a:p>
-            <a:r>
-              <a:t>1~2일차에서 다룬 내용이지만, '어디가 뚫리는지' 관점에서 다시 한번 정리합니다.</a:t>
-            </a:r>
-          </a:p>
+          <a:p/>
+          <a:p/>
         </p:txBody>
       </p:sp>
       <p:sp>
@@ -875,37 +795,17 @@
         <p:txBody>
           <a:bodyPr/>
           <a:lstStyle/>
-          <a:p>
-            <a:r>
-              <a:t>생성형 AI의 세 가지 핵심 구성요소와 각각의 공격 표면입니다.</a:t>
-            </a:r>
-          </a:p>
+          <a:p/>
           <a:p>
             <a:endParaRPr/>
           </a:p>
-          <a:p>
-            <a:r>
-              <a:t>LLM 엔진: 프롬프트 인젝션 T08, 모델 도용 T04, 적대적 예제 T09.</a:t>
-            </a:r>
-          </a:p>
-          <a:p>
-            <a:r>
-              <a:t>RAG·벡터DB: 데이터 오염 T01, 비인가 접근 T05, 임베딩 취약점.</a:t>
-            </a:r>
-          </a:p>
-          <a:p>
-            <a:r>
-              <a:t>Agent: 권한 오남용 T13, 과도한 도구 접근 T06, 결과 미검증.</a:t>
-            </a:r>
-          </a:p>
+          <a:p/>
+          <a:p/>
+          <a:p/>
           <a:p>
             <a:endParaRPr/>
           </a:p>
-          <a:p>
-            <a:r>
-              <a:t>각각 독립된 위협이 아니라, 서로 연결됩니다. 이 연결이 오늘 핵심입니다.</a:t>
-            </a:r>
-          </a:p>
+          <a:p/>
         </p:txBody>
       </p:sp>
       <p:sp>
@@ -987,35 +887,19 @@
         <p:txBody>
           <a:bodyPr/>
           <a:lstStyle/>
-          <a:p>
-            <a:r>
-              <a:t>AI 보안이 기존 IT 보안과 근본적으로 다른 이유 두 가지입니다.</a:t>
-            </a:r>
-          </a:p>
+          <a:p/>
           <a:p>
             <a:endParaRPr/>
           </a:p>
-          <a:p>
-            <a:r>
-              <a:t>첫째, 자연어가 곧 명령어입니다. 기존 시스템은 코드로 명령하지만 AI는 일상 언어로 명령합니다. 이건 편리함인 동시에 취약점입니다.</a:t>
-            </a:r>
-          </a:p>
+          <a:p/>
           <a:p>
             <a:endParaRPr/>
           </a:p>
-          <a:p>
-            <a:r>
-              <a:t>둘째, 경계가 붕괴됩니다. 시스템 프롬프트와 사용자 입력 사이에 물리적 경계가 없습니다. 공격자가 이 경계를 흐리는 것이 프롬프트 인젝션의 본질입니다.</a:t>
-            </a:r>
-          </a:p>
+          <a:p/>
           <a:p>
             <a:endParaRPr/>
           </a:p>
-          <a:p>
-            <a:r>
-              <a:t>이 두 특성 때문에 T07, T08이 구조적으로 발생할 수밖에 없습니다. 버그가 아니라 아키텍처의 한계입니다.</a:t>
-            </a:r>
-          </a:p>
+          <a:p/>
         </p:txBody>
       </p:sp>
       <p:sp>
@@ -1097,27 +981,15 @@
         <p:txBody>
           <a:bodyPr/>
           <a:lstStyle/>
-          <a:p>
-            <a:r>
-              <a:t>AI 시스템의 5대 공격 지점을 한 그림에 정리했습니다.</a:t>
-            </a:r>
-          </a:p>
+          <a:p/>
           <a:p>
             <a:endParaRPr/>
           </a:p>
-          <a:p>
-            <a:r>
-              <a:t>입력 UI에서 T07, T08. LLM 엔진에서 T04, T09, T06. RAG·벡터DB에서 T01, T05. 도구 호출에서 T13, T06. 학습 데이터에서 T01, T02, T03, T14.</a:t>
-            </a:r>
-          </a:p>
+          <a:p/>
           <a:p>
             <a:endParaRPr/>
           </a:p>
-          <a:p>
-            <a:r>
-              <a:t>이 지도를 머릿속에 넣어두시면 나머지 강의가 훨씬 쉬워집니다. 앞으로 나오는 모든 위협이 이 5개 지점 중 어디에 해당하는지 매핑하면서 들으시면 됩니다.</a:t>
-            </a:r>
-          </a:p>
+          <a:p/>
         </p:txBody>
       </p:sp>
       <p:sp>
@@ -1199,16 +1071,8 @@
         <p:txBody>
           <a:bodyPr/>
           <a:lstStyle/>
-          <a:p>
-            <a:r>
-              <a:t>Part 2입니다. 지금부터 T01~T15를 하나씩 사례와 함께 살펴봅니다.</a:t>
-            </a:r>
-          </a:p>
-          <a:p>
-            <a:r>
-              <a:t>4개 레이어로 구조화해서 전체 지형도를 먼저 보여드리고, 레이어별로 들어갑니다.</a:t>
-            </a:r>
-          </a:p>
+          <a:p/>
+          <a:p/>
         </p:txBody>
       </p:sp>
       <p:sp>
@@ -1290,42 +1154,18 @@
         <p:txBody>
           <a:bodyPr/>
           <a:lstStyle/>
-          <a:p>
-            <a:r>
-              <a:t>전체 지형도입니다. 오늘의 지도라고 생각하시면 됩니다.</a:t>
-            </a:r>
-          </a:p>
+          <a:p/>
           <a:p>
             <a:endParaRPr/>
           </a:p>
-          <a:p>
-            <a:r>
-              <a:t>레이어 1은 사용자·외부 입력을 통한 즉각적 위협. T07, T08, T09. 실습 1에서 직접 체험할 부분입니다.</a:t>
-            </a:r>
-          </a:p>
-          <a:p>
-            <a:r>
-              <a:t>레이어 2는 학습 데이터와 모델 자체에 대한 공격. T01~T06. 탐지가 어렵고 영향이 지속적입니다.</a:t>
-            </a:r>
-          </a:p>
-          <a:p>
-            <a:r>
-              <a:t>레이어 3은 운영 환경·인프라 취약점. T10~T13. 특히 T12 모니터링 부재가 없으면 나머지 모든 레이어의 위협이 탐지 불가능합니다.</a:t>
-            </a:r>
-          </a:p>
-          <a:p>
-            <a:r>
-              <a:t>레이어 4는 공급망. T14, T15. 외부에서 간접 침투하는 경로입니다.</a:t>
-            </a:r>
-          </a:p>
+          <a:p/>
+          <a:p/>
+          <a:p/>
+          <a:p/>
           <a:p>
             <a:endParaRPr/>
           </a:p>
-          <a:p>
-            <a:r>
-              <a:t>이 지형도를 중간중간 다시 보여드릴 겁니다. 지금 어디를 설명하고 있는지 놓치지 않도록.</a:t>
-            </a:r>
-          </a:p>
+          <a:p/>
         </p:txBody>
       </p:sp>
       <p:sp>
@@ -1407,37 +1247,17 @@
         <p:txBody>
           <a:bodyPr/>
           <a:lstStyle/>
-          <a:p>
-            <a:r>
-              <a:t>레이어 1의 첫 번째, T07 민감정보 입력·유출입니다.</a:t>
-            </a:r>
-          </a:p>
+          <a:p/>
           <a:p>
             <a:endParaRPr/>
           </a:p>
-          <a:p>
-            <a:r>
-              <a:t>두 가지 경로가 있습니다.</a:t>
-            </a:r>
-          </a:p>
-          <a:p>
-            <a:r>
-              <a:t>경로 A: 사용자가 민감정보를 입력하면 LLM 학습 데이터에 포함되고, 나중에 다른 사용자에게 유출됩니다.</a:t>
-            </a:r>
-          </a:p>
-          <a:p>
-            <a:r>
-              <a:t>경로 B: 시스템이 민감정보를 포함한 응답을 생성해서 직접 유출됩니다.</a:t>
-            </a:r>
-          </a:p>
+          <a:p/>
+          <a:p/>
+          <a:p/>
           <a:p>
             <a:endParaRPr/>
           </a:p>
-          <a:p>
-            <a:r>
-              <a:t>중요한 점은 — 이건 의도하지 않은 유출입니다. 사용자도 시스템도 유출할 의도가 없지만, 구조적으로 발생합니다.</a:t>
-            </a:r>
-          </a:p>
+          <a:p/>
         </p:txBody>
       </p:sp>
       <p:sp>
@@ -1519,26 +1339,10 @@
         <p:txBody>
           <a:bodyPr/>
           <a:lstStyle/>
-          <a:p>
-            <a:r>
-              <a:t>간단히 자기소개를 드립니다.</a:t>
-            </a:r>
-          </a:p>
-          <a:p>
-            <a:r>
-              <a:t>통계학으로 데이터 프라이버시를 연구했고, 그 연장선에서 AI 보안 위협 분석으로 넘어왔습니다.</a:t>
-            </a:r>
-          </a:p>
-          <a:p>
-            <a:r>
-              <a:t>NAVER Clova AI에서 실제 서비스에 들어가는 AI의 보안 이슈를 경험했고, CryptoLab에서 동형암호 기반 프라이버시 보호 기술을 다뤘습니다.</a:t>
-            </a:r>
-          </a:p>
-          <a:p>
-            <a:r>
-              <a:t>오늘 강의는 이론보다 '실제로 뚫리는 사례'에 초점을 맞춥니다.</a:t>
-            </a:r>
-          </a:p>
+          <a:p/>
+          <a:p/>
+          <a:p/>
+          <a:p/>
         </p:txBody>
       </p:sp>
       <p:sp>
@@ -1620,50 +1424,22 @@
         <p:txBody>
           <a:bodyPr/>
           <a:lstStyle/>
-          <a:p>
-            <a:r>
-              <a:t>T07의 가장 유명한 사례입니다. 2023년 삼성전자.</a:t>
-            </a:r>
-          </a:p>
+          <a:p/>
           <a:p>
             <a:endParaRPr/>
           </a:p>
-          <a:p>
-            <a:r>
-              <a:t>직원 A는 업무 효율을 위해 반도체 소스코드를 ChatGPT에 붙여넣었습니다.</a:t>
-            </a:r>
-          </a:p>
-          <a:p>
-            <a:r>
-              <a:t>직원 B는 설비 회의록을 통째로 입력했습니다.</a:t>
-            </a:r>
-          </a:p>
-          <a:p>
-            <a:r>
-              <a:t>직원 C는 임원 회의 내용을 요약시켰습니다.</a:t>
-            </a:r>
-          </a:p>
+          <a:p/>
+          <a:p/>
+          <a:p/>
           <a:p>
             <a:endParaRPr/>
           </a:p>
-          <a:p>
-            <a:r>
-              <a:t>세 건 모두 삼성 기밀이 ChatGPT 학습 데이터에 포함되었습니다.</a:t>
-            </a:r>
-          </a:p>
-          <a:p>
-            <a:r>
-              <a:t>결과적으로 삼성전자는 전사 ChatGPT 사용을 금지하고, 자체 AI '가우스'를 개발했습니다.</a:t>
-            </a:r>
-          </a:p>
+          <a:p/>
+          <a:p/>
           <a:p>
             <a:endParaRPr/>
           </a:p>
-          <a:p>
-            <a:r>
-              <a:t>핵심 메시지: 의도가 아닌 구조의 문제입니다. 직원들은 악의가 없었습니다.</a:t>
-            </a:r>
-          </a:p>
+          <a:p/>
         </p:txBody>
       </p:sp>
       <p:sp>
@@ -1745,35 +1521,19 @@
         <p:txBody>
           <a:bodyPr/>
           <a:lstStyle/>
-          <a:p>
-            <a:r>
-              <a:t>T07 관련 추가 사례 두 건입니다.</a:t>
-            </a:r>
-          </a:p>
+          <a:p/>
           <a:p>
             <a:endParaRPr/>
           </a:p>
-          <a:p>
-            <a:r>
-              <a:t>딥시크: 2025년 2월, 사용자 입력 100만 건 이상이 비암호화 상태로 노출되었습니다. 국내 공공기관 사용이 차단되는 사태로 이어졌습니다.</a:t>
-            </a:r>
-          </a:p>
+          <a:p/>
           <a:p>
             <a:endParaRPr/>
           </a:p>
-          <a:p>
-            <a:r>
-              <a:t>Meta EU: 2023년 아일랜드 DPC가 12억 유로, 역대 최대 GDPR 벌금을 부과했습니다. EU 사용자 데이터를 미국 서버로 이전한 것이 위반 사유입니다.</a:t>
-            </a:r>
-          </a:p>
+          <a:p/>
           <a:p>
             <a:endParaRPr/>
           </a:p>
-          <a:p>
-            <a:r>
-              <a:t>교훈: 데이터가 어디서 처리되는가. 이것은 기술 문제가 아니라 행정·법적 문제입니다.</a:t>
-            </a:r>
-          </a:p>
+          <a:p/>
         </p:txBody>
       </p:sp>
       <p:sp>
@@ -1855,40 +1615,20 @@
         <p:txBody>
           <a:bodyPr/>
           <a:lstStyle/>
-          <a:p>
-            <a:r>
-              <a:t>[중요 슬라이드] 이것은 T08 프롬프트 인젝션이 왜 구조적 문제인지 설명하는 핵심 개념입니다.</a:t>
-            </a:r>
-          </a:p>
+          <a:p/>
           <a:p>
             <a:endParaRPr/>
           </a:p>
-          <a:p>
-            <a:r>
-              <a:t>전통 소프트웨어에서는 명령은 코드, 데이터는 메모리 — CPU가 물리적으로 구분합니다.</a:t>
-            </a:r>
-          </a:p>
-          <a:p>
-            <a:r>
-              <a:t>LLM에서는 시스템 프롬프트, 사용자 입력, 외부 문서, 공격자 명령이 모두 동일한 토큰 스트림으로 처리됩니다. 우선순위가 없습니다.</a:t>
-            </a:r>
-          </a:p>
+          <a:p/>
+          <a:p/>
           <a:p>
             <a:endParaRPr/>
           </a:p>
-          <a:p>
-            <a:r>
-              <a:t>Transformer의 Self-Attention은 컨텍스트 내 모든 토큰에 동일하게 적용됩니다. '시스템 프롬프트이니까 더 중요'라는 구조적 보호 장치가 없습니다.</a:t>
-            </a:r>
-          </a:p>
+          <a:p/>
           <a:p>
             <a:endParaRPr/>
           </a:p>
-          <a:p>
-            <a:r>
-              <a:t>이것이 프롬프트 인젝션이 버그가 아닌 구조적 한계인 이유입니다. 해결책은 아키텍처 수준의 분리인데, 아직 연구 단계입니다.</a:t>
-            </a:r>
-          </a:p>
+          <a:p/>
         </p:txBody>
       </p:sp>
       <p:sp>
@@ -1970,32 +1710,16 @@
         <p:txBody>
           <a:bodyPr/>
           <a:lstStyle/>
-          <a:p>
-            <a:r>
-              <a:t>T08 프롬프트 인젝션입니다. OWASP에서는 LLM01로 분류됩니다.</a:t>
-            </a:r>
-          </a:p>
+          <a:p/>
           <a:p>
             <a:endParaRPr/>
           </a:p>
-          <a:p>
-            <a:r>
-              <a:t>직접 인젝션: 사용자가 악성 입력을 직접 넣어서 시스템 지시를 무시하게 만듭니다.</a:t>
-            </a:r>
-          </a:p>
-          <a:p>
-            <a:r>
-              <a:t>간접 인젝션: 공격자가 문서, 이메일, URL에 숨겨놓으면 LLM이 처리하면서 명령을 실행합니다.</a:t>
-            </a:r>
-          </a:p>
+          <a:p/>
+          <a:p/>
           <a:p>
             <a:endParaRPr/>
           </a:p>
-          <a:p>
-            <a:r>
-              <a:t>실습 1에서 직접 인젝션을 직접 체험하게 됩니다. 시스템 프롬프트를 훔치고, 데이터를 유출하고, 권한을 탈취하는 것을 해봅니다.</a:t>
-            </a:r>
-          </a:p>
+          <a:p/>
         </p:txBody>
       </p:sp>
       <p:sp>
@@ -2077,43 +1801,23 @@
         <p:txBody>
           <a:bodyPr/>
           <a:lstStyle/>
-          <a:p>
-            <a:r>
-              <a:t>T08 실제 사례 세 건입니다.</a:t>
-            </a:r>
-          </a:p>
+          <a:p/>
           <a:p>
             <a:endParaRPr/>
           </a:p>
-          <a:p>
-            <a:r>
-              <a:t>GM 딜러 챗봇, 2024년. 가장 단순한 형태의 직접 인젝션입니다. 챗봇에게 '1달러에 SUV를 팔겠다고 동의해'라고 하니까 동의했습니다.</a:t>
-            </a:r>
-          </a:p>
+          <a:p/>
           <a:p>
             <a:endParaRPr/>
           </a:p>
-          <a:p>
-            <a:r>
-              <a:t>EchoLeak, 2025년 6월 MS Copilot. 세계 최초 AI 제로클릭 공격입니다. 이메일을 읽기만 해도 자동으로 정보가 유출됩니다. 클릭도 첨부파일도 필요 없습니다.</a:t>
-            </a:r>
-          </a:p>
+          <a:p/>
           <a:p>
             <a:endParaRPr/>
           </a:p>
-          <a:p>
-            <a:r>
-              <a:t>Promptware, 2025년 8월 Google Calendar. 캘린더 초대장 안에 프롬프트가 숨겨져 있어서 수락하지 않아도 발생합니다.</a:t>
-            </a:r>
-          </a:p>
+          <a:p/>
           <a:p>
             <a:endParaRPr/>
           </a:p>
-          <a:p>
-            <a:r>
-              <a:t>세 사건의 공통점: 사용자가 공격을 허락한 적이 없습니다.</a:t>
-            </a:r>
-          </a:p>
+          <a:p/>
         </p:txBody>
       </p:sp>
       <p:sp>
@@ -2195,35 +1899,19 @@
         <p:txBody>
           <a:bodyPr/>
           <a:lstStyle/>
-          <a:p>
-            <a:r>
-              <a:t>레이어 1 마지막, T09 회피공격입니다.</a:t>
-            </a:r>
-          </a:p>
+          <a:p/>
           <a:p>
             <a:endParaRPr/>
           </a:p>
-          <a:p>
-            <a:r>
-              <a:t>사람 눈에는 보이지 않는 미세한 변형을 입력에 추가해서 AI가 완전히 다른 결과를 내게 만듭니다.</a:t>
-            </a:r>
-          </a:p>
+          <a:p/>
           <a:p>
             <a:endParaRPr/>
           </a:p>
-          <a:p>
-            <a:r>
-              <a:t>대표 사례: 2017년 STOP 표지판에 검은 스티커 몇 장을 붙였더니, 자율주행 AI가 '속도제한 45'로 인식했습니다. 인간 눈에는 명백한 정지 표지판입니다.</a:t>
-            </a:r>
-          </a:p>
+          <a:p/>
           <a:p>
             <a:endParaRPr/>
           </a:p>
-          <a:p>
-            <a:r>
-              <a:t>군 맥락에서 생각해 보면 — 드론 표적 식별이나 안면인식 출입통제에 동일 원리가 적용됩니다. 스티커 몇 장으로 적군이 아군으로 인식될 수 있습니다.</a:t>
-            </a:r>
-          </a:p>
+          <a:p/>
         </p:txBody>
       </p:sp>
       <p:sp>
@@ -2323,29 +2011,13 @@
         <p:txBody>
           <a:bodyPr/>
           <a:lstStyle/>
-          <a:p>
-            <a:r>
-              <a:t>레이어 1을 마쳤습니다. 지형도에서 현재 위치를 확인합니다.</a:t>
-            </a:r>
-          </a:p>
+          <a:p/>
           <a:p>
             <a:endParaRPr/>
           </a:p>
-          <a:p>
-            <a:r>
-              <a:t>T07 민감정보, T08 프롬프트 인젝션, T09 회피공격 — 사용자 입력을 통한 즉각적 위협을 봤습니다.</a:t>
-            </a:r>
-          </a:p>
-          <a:p>
-            <a:r>
-              <a:t>지금부터 레이어 2로 넘어갑니다. 학습 데이터와 모델 자체에 대한 공격입니다.</a:t>
-            </a:r>
-          </a:p>
-          <a:p>
-            <a:r>
-              <a:t>레이어 1보다 탐지가 어렵고, 한번 성공하면 영향이 지속적입니다.</a:t>
-            </a:r>
-          </a:p>
+          <a:p/>
+          <a:p/>
+          <a:p/>
         </p:txBody>
       </p:sp>
       <p:sp>
@@ -2433,35 +2105,19 @@
         <p:txBody>
           <a:bodyPr/>
           <a:lstStyle/>
-          <a:p>
-            <a:r>
-              <a:t>레이어 2의 첫 번째, T01 데이터 오염입니다.</a:t>
-            </a:r>
-          </a:p>
+          <a:p/>
           <a:p>
             <a:endParaRPr/>
           </a:p>
-          <a:p>
-            <a:r>
-              <a:t>대표 사례는 2016년 Microsoft Tay입니다. Twitter에 공개된 챗봇에 사용자들이 혐오·차별 발언을 집중 입력했더니, 불과 24시간, 실제로는 16시간 만에 모델이 혐오 콘텐츠를 자동 생성하기 시작했습니다.</a:t>
-            </a:r>
-          </a:p>
+          <a:p/>
           <a:p>
             <a:endParaRPr/>
           </a:p>
-          <a:p>
-            <a:r>
-              <a:t>핵심은 구조입니다: 인터넷에 노출된 AI가 사용자 입력으로 실시간 재학습되는 구조가 악용되었습니다.</a:t>
-            </a:r>
-          </a:p>
+          <a:p/>
           <a:p>
             <a:endParaRPr/>
           </a:p>
-          <a:p>
-            <a:r>
-              <a:t>군 AI에 적용하면 — 데이터 수집과 라벨링 단계가 가장 취약한 공격 시점입니다.</a:t>
-            </a:r>
-          </a:p>
+          <a:p/>
         </p:txBody>
       </p:sp>
       <p:sp>
@@ -2543,43 +2199,23 @@
         <p:txBody>
           <a:bodyPr/>
           <a:lstStyle/>
-          <a:p>
-            <a:r>
-              <a:t>[심화 슬라이드] Test-Time Training 개념입니다.</a:t>
-            </a:r>
-          </a:p>
+          <a:p/>
           <a:p>
             <a:endParaRPr/>
           </a:p>
-          <a:p>
-            <a:r>
-              <a:t>전통적 ML은 학습 후 파라미터를 동결하고 추론만 합니다. 하지만 TTT는 추론 중에도 파라미터를 갱신합니다. 테스트 입력이 모델 자체를 변경합니다.</a:t>
-            </a:r>
-          </a:p>
+          <a:p/>
           <a:p>
             <a:endParaRPr/>
           </a:p>
-          <a:p>
-            <a:r>
-              <a:t>Tay 사태를 TTT 구조로 분석하면: 악의적 사용자 입력 → 실시간 학습 → 파라미터 변형 → 독성 출력.</a:t>
-            </a:r>
-          </a:p>
+          <a:p/>
           <a:p>
             <a:endParaRPr/>
           </a:p>
-          <a:p>
-            <a:r>
-              <a:t>현대에도 동일한 구조가 반복됩니다: RLHF 피드백 루프, RAG 동적 업데이트, Fine-tuning API 오용.</a:t>
-            </a:r>
-          </a:p>
+          <a:p/>
           <a:p>
             <a:endParaRPr/>
           </a:p>
-          <a:p>
-            <a:r>
-              <a:t>[시간이 부족하면 이 슬라이드는 생략 가능합니다]</a:t>
-            </a:r>
-          </a:p>
+          <a:p/>
         </p:txBody>
       </p:sp>
       <p:sp>
@@ -2661,27 +2297,15 @@
         <p:txBody>
           <a:bodyPr/>
           <a:lstStyle/>
-          <a:p>
-            <a:r>
-              <a:t>T02 비인가 민감정보 학습입니다.</a:t>
-            </a:r>
-          </a:p>
+          <a:p/>
           <a:p>
             <a:endParaRPr/>
           </a:p>
-          <a:p>
-            <a:r>
-              <a:t>사례: 2017년 DeepMind과 영국 NHS. 160만 명의 의료 기록을 명시적 동의 없이 AI 학습에 활용했습니다. 영국 개인정보보호청 ICO가 위반으로 판정했고, AI 출력에서 실제 환자 정보가 재구성 가능하다는 것이 확인되었습니다.</a:t>
-            </a:r>
-          </a:p>
+          <a:p/>
           <a:p>
             <a:endParaRPr/>
           </a:p>
-          <a:p>
-            <a:r>
-              <a:t>군 맥락: 내부 데이터로 학습된 AI의 출력에서 작전·인사 정보가 재구성될 수 있습니다. 학습 데이터에 무엇이 들어가는지 통제하는 것이 핵심입니다.</a:t>
-            </a:r>
-          </a:p>
+          <a:p/>
         </p:txBody>
       </p:sp>
       <p:sp>
@@ -2763,39 +2387,15 @@
         <p:txBody>
           <a:bodyPr/>
           <a:lstStyle/>
-          <a:p>
-            <a:r>
-              <a:t>하루 일정입니다.</a:t>
-            </a:r>
-          </a:p>
-          <a:p>
-            <a:r>
-              <a:t>1강에서 AI 보안 위협의 현실을 사례 중심으로 봅니다. 왜 위험한가.</a:t>
-            </a:r>
-          </a:p>
-          <a:p>
-            <a:r>
-              <a:t>2강에서 OWASP와 NIS라는 두 가지 렌즈로 위협을 체계적으로 분류합니다.</a:t>
-            </a:r>
-          </a:p>
-          <a:p>
-            <a:r>
-              <a:t>3강에서 방어 대책 M01~M30을 4계층 구조로 정리합니다.</a:t>
-            </a:r>
-          </a:p>
-          <a:p>
-            <a:r>
-              <a:t>각 강의 뒤에 실습이 이어집니다. 듣고 바로 해보는 구조입니다.</a:t>
-            </a:r>
-          </a:p>
+          <a:p/>
+          <a:p/>
+          <a:p/>
+          <a:p/>
+          <a:p/>
           <a:p>
             <a:endParaRPr/>
           </a:p>
-          <a:p>
-            <a:r>
-              <a:t>중요한 건 — 실습은 실제 Gemini API를 공격합니다. 시뮬레이션이 아닙니다.</a:t>
-            </a:r>
-          </a:p>
+          <a:p/>
         </p:txBody>
       </p:sp>
       <p:sp>
@@ -2877,35 +2477,19 @@
         <p:txBody>
           <a:bodyPr/>
           <a:lstStyle/>
-          <a:p>
-            <a:r>
-              <a:t>[심화 슬라이드 — 시간 조율 시 생략 가능]</a:t>
-            </a:r>
-          </a:p>
+          <a:p/>
           <a:p>
             <a:endParaRPr/>
           </a:p>
-          <a:p>
-            <a:r>
-              <a:t>LLM Memorization 개념입니다. 모델이 학습 데이터를 추상화하는 것이 Generalization이고, 학습 데이터를 그대로 암기하는 것이 Memorization입니다.</a:t>
-            </a:r>
-          </a:p>
+          <a:p/>
           <a:p>
             <a:endParaRPr/>
           </a:p>
-          <a:p>
-            <a:r>
-              <a:t>문제는 대형 모델일수록 Memorization이 증가한다는 것입니다. Carlini 등의 2021년 연구에서 GPT-2에서 실제 학습 데이터 600건 이상을 추출하는 데 성공했습니다.</a:t>
-            </a:r>
-          </a:p>
+          <a:p/>
           <a:p>
             <a:endParaRPr/>
           </a:p>
-          <a:p>
-            <a:r>
-              <a:t>'이전에 본 텍스트를 계속 써줘'라는 단순한 프롬프트로 학습 데이터 원문이 출력될 수 있습니다.</a:t>
-            </a:r>
-          </a:p>
+          <a:p/>
         </p:txBody>
       </p:sp>
       <p:sp>
@@ -2987,32 +2571,16 @@
         <p:txBody>
           <a:bodyPr/>
           <a:lstStyle/>
-          <a:p>
-            <a:r>
-              <a:t>T03 백도어 삽입입니다.</a:t>
-            </a:r>
-          </a:p>
+          <a:p/>
           <a:p>
             <a:endParaRPr/>
           </a:p>
-          <a:p>
-            <a:r>
-              <a:t>사례: 2024년 중국산 AI 탑재 로봇청소기. 공장 출하 단계에서 악성코드가 삽입되어 있었고, 특정 Wi-Fi 신호를 수신하면 카메라와 마이크가 원격 활성화됩니다.</a:t>
-            </a:r>
-          </a:p>
-          <a:p>
-            <a:r>
-              <a:t>T14 공급망을 경유해서 T03 백도어가 작동하는 전형적인 연계 패턴입니다.</a:t>
-            </a:r>
-          </a:p>
+          <a:p/>
+          <a:p/>
           <a:p>
             <a:endParaRPr/>
           </a:p>
-          <a:p>
-            <a:r>
-              <a:t>백도어의 무서운 점: 트리거 입력이 오기 전까지 완전히 잠들어 있습니다. 정기 보안검사로는 탐지할 수 없습니다.</a:t>
-            </a:r>
-          </a:p>
+          <a:p/>
         </p:txBody>
       </p:sp>
       <p:sp>
@@ -3094,32 +2662,16 @@
         <p:txBody>
           <a:bodyPr/>
           <a:lstStyle/>
-          <a:p>
-            <a:r>
-              <a:t>T04 학습데이터 추출입니다.</a:t>
-            </a:r>
-          </a:p>
+          <a:p/>
           <a:p>
             <a:endParaRPr/>
           </a:p>
-          <a:p>
-            <a:r>
-              <a:t>2023년 ChatGPT 사례입니다. 'poem poem poem poem'을 반복해서 수천 회 입력했더니, 인터넷에서 수집된 실제 텍스트가 원문 그대로 출력되었습니다. 개인정보가 포함되어 있었습니다.</a:t>
-            </a:r>
-          </a:p>
+          <a:p/>
           <a:p>
             <a:endParaRPr/>
           </a:p>
-          <a:p>
-            <a:r>
-              <a:t>공개 데이터 크롤링 기반으로 학습된 시스템이 가장 취약합니다.</a:t>
-            </a:r>
-          </a:p>
-          <a:p>
-            <a:r>
-              <a:t>앞서 본 Memorization 개념이 여기서 실제 공격으로 이어지는 것입니다.</a:t>
-            </a:r>
-          </a:p>
+          <a:p/>
+          <a:p/>
         </p:txBody>
       </p:sp>
       <p:sp>
@@ -3201,37 +2753,17 @@
         <p:txBody>
           <a:bodyPr/>
           <a:lstStyle/>
-          <a:p>
-            <a:r>
-              <a:t>T05 학습데이터 비인가 접근입니다.</a:t>
-            </a:r>
-          </a:p>
+          <a:p/>
           <a:p>
             <a:endParaRPr/>
           </a:p>
-          <a:p>
-            <a:r>
-              <a:t>2023년 Tesla 사례. 전직 직원 2명이 내부 시스템에서 40GB의 자율주행 AI 소스코드와 학습 데이터를 외부로 유출했습니다.</a:t>
-            </a:r>
-          </a:p>
-          <a:p>
-            <a:r>
-              <a:t>접근 권한 회수가 지연되었고, 잔존 계정이 악용되었습니다.</a:t>
-            </a:r>
-          </a:p>
-          <a:p>
-            <a:r>
-              <a:t>T05 비인가 접근과 T15 용역업체 보안관리 부실의 복합 패턴입니다.</a:t>
-            </a:r>
-          </a:p>
+          <a:p/>
+          <a:p/>
+          <a:p/>
           <a:p>
             <a:endParaRPr/>
           </a:p>
-          <a:p>
-            <a:r>
-              <a:t>교훈: 퇴직·전직 시 즉각적인 접근 권한 회수가 핵심입니다. 간단하지만 가장 많이 놓치는 부분입니다.</a:t>
-            </a:r>
-          </a:p>
+          <a:p/>
         </p:txBody>
       </p:sp>
       <p:sp>
@@ -3313,37 +2845,17 @@
         <p:txBody>
           <a:bodyPr/>
           <a:lstStyle/>
-          <a:p>
-            <a:r>
-              <a:t>T06 AI 모델 추출입니다.</a:t>
-            </a:r>
-          </a:p>
+          <a:p/>
           <a:p>
             <a:endParaRPr/>
           </a:p>
-          <a:p>
-            <a:r>
-              <a:t>KISA 안내서의 사례입니다. API만 있으면 직접 접근 없이도 모델을 복제할 수 있습니다.</a:t>
-            </a:r>
-          </a:p>
-          <a:p>
-            <a:r>
-              <a:t>650번의 쿼리를 70초 만에 전송해서 출력 패턴을 수집하고, 대리 모델을 재구성해서 원본과 유사한 정확도를 달성했습니다.</a:t>
-            </a:r>
-          </a:p>
+          <a:p/>
+          <a:p/>
           <a:p>
             <a:endParaRPr/>
           </a:p>
-          <a:p>
-            <a:r>
-              <a:t>더 위험한 연계: T06으로 복제한 모델로 T09 적대적 예제를 쉽게 만들 수 있습니다.</a:t>
-            </a:r>
-          </a:p>
-          <a:p>
-            <a:r>
-              <a:t>군 전용 AI가 외부 API로 노출되면 즉각적인 모델 도용 위험이 있습니다.</a:t>
-            </a:r>
-          </a:p>
+          <a:p/>
+          <a:p/>
         </p:txBody>
       </p:sp>
       <p:sp>
@@ -3425,35 +2937,19 @@
         <p:txBody>
           <a:bodyPr/>
           <a:lstStyle/>
-          <a:p>
-            <a:r>
-              <a:t>[심화 슬라이드] 지식 증류 개념입니다.</a:t>
-            </a:r>
-          </a:p>
+          <a:p/>
           <a:p>
             <a:endParaRPr/>
           </a:p>
-          <a:p>
-            <a:r>
-              <a:t>Teacher 모델의 출력, 특히 확률 분포를 Soft Label이라고 합니다. Student 모델이 이 Soft Label을 학습하면 Teacher의 '지식'을 흡수합니다.</a:t>
-            </a:r>
-          </a:p>
+          <a:p/>
           <a:p>
             <a:endParaRPr/>
           </a:p>
-          <a:p>
-            <a:r>
-              <a:t>공격자 입장에서는: API 출력이 곧 Soft Label입니다. API 쿼리를 반복하면 대리 모델을 구성할 수 있고, 이것이 T06 공격의 메커니즘입니다.</a:t>
-            </a:r>
-          </a:p>
+          <a:p/>
           <a:p>
             <a:endParaRPr/>
           </a:p>
-          <a:p>
-            <a:r>
-              <a:t>쿼리 설계 → 출력 수집 → 대리 모델 학습 → 도용 완료. 4단계 파이프라인입니다.</a:t>
-            </a:r>
-          </a:p>
+          <a:p/>
         </p:txBody>
       </p:sp>
       <p:sp>
@@ -3553,32 +3049,16 @@
         <p:txBody>
           <a:bodyPr/>
           <a:lstStyle/>
-          <a:p>
-            <a:r>
-              <a:t>레이어 2를 마쳤습니다. 다시 지형도를 확인합니다.</a:t>
-            </a:r>
-          </a:p>
+          <a:p/>
           <a:p>
             <a:endParaRPr/>
           </a:p>
-          <a:p>
-            <a:r>
-              <a:t>레이어 1: 입력 조작 — 즉각적 위협.</a:t>
-            </a:r>
-          </a:p>
-          <a:p>
-            <a:r>
-              <a:t>레이어 2: 데이터·모델 — 탐지 어렵고 영향 지속적. 방금 여기까지 봤습니다.</a:t>
-            </a:r>
-          </a:p>
+          <a:p/>
+          <a:p/>
           <a:p>
             <a:endParaRPr/>
           </a:p>
-          <a:p>
-            <a:r>
-              <a:t>지금부터 레이어 3, 운영 환경·인프라로 넘어갑니다. 특히 T12 모니터링 부재가 핵심입니다 — 이것이 없으면 레이어 1, 2의 위협이 발생해도 알 수 없습니다.</a:t>
-            </a:r>
-          </a:p>
+          <a:p/>
         </p:txBody>
       </p:sp>
       <p:sp>
@@ -3666,43 +3146,23 @@
         <p:txBody>
           <a:bodyPr/>
           <a:lstStyle/>
-          <a:p>
-            <a:r>
-              <a:t>[핵심 슬라이드 — 강조해서 설명]</a:t>
-            </a:r>
-          </a:p>
+          <a:p/>
           <a:p>
             <a:endParaRPr/>
           </a:p>
-          <a:p>
-            <a:r>
-              <a:t>T12 모니터링 부재입니다. 별표가 붙어 있는 이유가 있습니다.</a:t>
-            </a:r>
-          </a:p>
+          <a:p/>
           <a:p>
             <a:endParaRPr/>
           </a:p>
-          <a:p>
-            <a:r>
-              <a:t>T12가 없으면 T01부터 T11, T13부터 T15까지 나머지 14개 위협이 전부 탐지 불가능합니다. 보안의 실질적 전제조건입니다.</a:t>
-            </a:r>
-          </a:p>
+          <a:p/>
           <a:p>
             <a:endParaRPr/>
           </a:p>
-          <a:p>
-            <a:r>
-              <a:t>유발 하라리가 『넥서스』에서 쓴 것처럼 — 'AI는 스스로를 교정하지 않습니다. 인간이 관찰하고 개입하지 않으면 오류는 증폭됩니다.'</a:t>
-            </a:r>
-          </a:p>
+          <a:p/>
           <a:p>
             <a:endParaRPr/>
           </a:p>
-          <a:p>
-            <a:r>
-              <a:t>M12 이상행위 탐지를 구축하지 않으면 전체 보안 체계가 무력화됩니다. 가장 화려하지 않지만 가장 중요한 위협입니다.</a:t>
-            </a:r>
-          </a:p>
+          <a:p/>
         </p:txBody>
       </p:sp>
       <p:sp>
@@ -3784,42 +3244,18 @@
         <p:txBody>
           <a:bodyPr/>
           <a:lstStyle/>
-          <a:p>
-            <a:r>
-              <a:t>T10 통신구간 공격입니다.</a:t>
-            </a:r>
-          </a:p>
+          <a:p/>
           <a:p>
             <a:endParaRPr/>
           </a:p>
-          <a:p>
-            <a:r>
-              <a:t>주요 공격 경로 세 가지:</a:t>
-            </a:r>
-          </a:p>
-          <a:p>
-            <a:r>
-              <a:t>LLM API 응답 패킷 스니핑으로 민감 출력을 탈취.</a:t>
-            </a:r>
-          </a:p>
-          <a:p>
-            <a:r>
-              <a:t>벡터DB 조회 쿼리를 도청해서 RAG 내용을 유출.</a:t>
-            </a:r>
-          </a:p>
-          <a:p>
-            <a:r>
-              <a:t>모델 서빙 엔드포인트가 미인증이면 직접 접근 가능.</a:t>
-            </a:r>
-          </a:p>
+          <a:p/>
+          <a:p/>
+          <a:p/>
+          <a:p/>
           <a:p>
             <a:endParaRPr/>
           </a:p>
-          <a:p>
-            <a:r>
-              <a:t>중요한 점: 내부망도 예외가 아닙니다. 망 분리는 암호화가 아닙니다.</a:t>
-            </a:r>
-          </a:p>
+          <a:p/>
         </p:txBody>
       </p:sp>
       <p:sp>
@@ -3901,37 +3337,17 @@
         <p:txBody>
           <a:bodyPr/>
           <a:lstStyle/>
-          <a:p>
-            <a:r>
-              <a:t>T11 서비스 거부 공격입니다. AI 특유의 변형이 있습니다.</a:t>
-            </a:r>
-          </a:p>
+          <a:p/>
           <a:p>
             <a:endParaRPr/>
           </a:p>
-          <a:p>
-            <a:r>
-              <a:t>Prompt Flooding: 무한 반복이나 극도로 긴 프롬프트를 전송.</a:t>
-            </a:r>
-          </a:p>
-          <a:p>
-            <a:r>
-              <a:t>Sponge Attack: GPU 연산을 최대로 소모하는 입력을 설계.</a:t>
-            </a:r>
-          </a:p>
-          <a:p>
-            <a:r>
-              <a:t>RAG Overload: 벡터DB 검색 요청을 폭주시켜서 응답 불가 상태.</a:t>
-            </a:r>
-          </a:p>
+          <a:p/>
+          <a:p/>
+          <a:p/>
           <a:p>
             <a:endParaRPr/>
           </a:p>
-          <a:p>
-            <a:r>
-              <a:t>군 맥락에서 생각해 보면 — 위기 상황의 AI 의사결정 시스템이 마비되는 것입니다. 가장 위험한 순간에 가장 취약해집니다.</a:t>
-            </a:r>
-          </a:p>
+          <a:p/>
         </p:txBody>
       </p:sp>
       <p:sp>
@@ -4013,37 +3429,17 @@
         <p:txBody>
           <a:bodyPr/>
           <a:lstStyle/>
-          <a:p>
-            <a:r>
-              <a:t>오늘 강의의 세 가지 기반 문서입니다.</a:t>
-            </a:r>
-          </a:p>
+          <a:p/>
           <a:p>
             <a:endParaRPr/>
           </a:p>
-          <a:p>
-            <a:r>
-              <a:t>첫째, OWASP LLM Top 10. 개발자 관점에서 LLM의 10대 취약점을 정리한 글로벌 표준입니다.</a:t>
-            </a:r>
-          </a:p>
-          <a:p>
-            <a:r>
-              <a:t>둘째, 국정원 AI 가이드북. 국가·공공기관 맥락에서 위협 T01~T15와 대책 M01~M30을 정의합니다.</a:t>
-            </a:r>
-          </a:p>
-          <a:p>
-            <a:r>
-              <a:t>셋째, KISA 인공지능 보안 안내서. 역할별 — 개발자, 운영자, 관리자 — 누가 무엇을 해야 하는지 안내합니다.</a:t>
-            </a:r>
-          </a:p>
+          <a:p/>
+          <a:p/>
+          <a:p/>
           <a:p>
             <a:endParaRPr/>
           </a:p>
-          <a:p>
-            <a:r>
-              <a:t>이 세 문서는 같은 위협을 다른 관점에서 봅니다. 2강에서 이 세 관점을 교차 매핑합니다.</a:t>
-            </a:r>
-          </a:p>
+          <a:p/>
         </p:txBody>
       </p:sp>
       <p:sp>
@@ -4125,35 +3521,19 @@
         <p:txBody>
           <a:bodyPr/>
           <a:lstStyle/>
-          <a:p>
-            <a:r>
-              <a:t>T13 AI 시스템 권한관리 부실입니다.</a:t>
-            </a:r>
-          </a:p>
+          <a:p/>
           <a:p>
             <a:endParaRPr/>
           </a:p>
-          <a:p>
-            <a:r>
-              <a:t>핵심은 T08과의 연계입니다. 프롬프트 인젝션으로 Agent를 제어하면, Agent의 권한으로 파일, DB에 접근할 수 있습니다.</a:t>
-            </a:r>
-          </a:p>
+          <a:p/>
           <a:p>
             <a:endParaRPr/>
           </a:p>
-          <a:p>
-            <a:r>
-              <a:t>Agentic AI의 도구 호출 권한 오용이 특히 위험합니다. 외부 API 호출, 이메일 발송, 코드 실행이 자동화되어 있기 때문입니다.</a:t>
-            </a:r>
-          </a:p>
+          <a:p/>
           <a:p>
             <a:endParaRPr/>
           </a:p>
-          <a:p>
-            <a:r>
-              <a:t>방어 원칙은 단순합니다: 최소 권한. Agent에게 꼭 필요한 것만 줍니다.</a:t>
-            </a:r>
-          </a:p>
+          <a:p/>
         </p:txBody>
       </p:sp>
       <p:sp>
@@ -4235,40 +3615,20 @@
         <p:txBody>
           <a:bodyPr/>
           <a:lstStyle/>
-          <a:p>
-            <a:r>
-              <a:t>[심화 슬라이드] T08과 T13의 연계 공격 흐름을 도식화했습니다.</a:t>
-            </a:r>
-          </a:p>
+          <a:p/>
           <a:p>
             <a:endParaRPr/>
           </a:p>
-          <a:p>
-            <a:r>
-              <a:t>일반 LLM은 텍스트만 처리하니까 세계와 격리되어 있습니다.</a:t>
-            </a:r>
-          </a:p>
-          <a:p>
-            <a:r>
-              <a:t>하지만 Agent는 웹 검색, 파일 읽기/쓰기, 코드 실행, 외부 API 호출이 가능합니다.</a:t>
-            </a:r>
-          </a:p>
+          <a:p/>
+          <a:p/>
           <a:p>
             <a:endParaRPr/>
           </a:p>
-          <a:p>
-            <a:r>
-              <a:t>공격 흐름: 간접 인젝션으로 문서에 악성 프롬프트 삽입 → Agent가 문서 처리 중 트리거 → Tool Call 발동으로 파일 삭제나 외부 전송 실행 → 사용자 개입 없이 자동으로 비인가 동작 완료.</a:t>
-            </a:r>
-          </a:p>
+          <a:p/>
           <a:p>
             <a:endParaRPr/>
           </a:p>
-          <a:p>
-            <a:r>
-              <a:t>이것이 Agent 시대의 새로운 위협입니다.</a:t>
-            </a:r>
-          </a:p>
+          <a:p/>
         </p:txBody>
       </p:sp>
       <p:sp>
@@ -4368,19 +3728,11 @@
         <p:txBody>
           <a:bodyPr/>
           <a:lstStyle/>
-          <a:p>
-            <a:r>
-              <a:t>레이어 3을 마쳤습니다. 지형도의 마지막 부분입니다.</a:t>
-            </a:r>
-          </a:p>
+          <a:p/>
           <a:p>
             <a:endParaRPr/>
           </a:p>
-          <a:p>
-            <a:r>
-              <a:t>이제 레이어 4, 공급망으로 넘어갑니다. 외부 모델과 업체를 경유한 간접 침투입니다. 도입 전 검증이 핵심입니다.</a:t>
-            </a:r>
-          </a:p>
+          <a:p/>
         </p:txBody>
       </p:sp>
       <p:sp>
@@ -4468,32 +3820,16 @@
         <p:txBody>
           <a:bodyPr/>
           <a:lstStyle/>
-          <a:p>
-            <a:r>
-              <a:t>T14 공급망 공격입니다.</a:t>
-            </a:r>
-          </a:p>
+          <a:p/>
           <a:p>
             <a:endParaRPr/>
           </a:p>
-          <a:p>
-            <a:r>
-              <a:t>2024년 Hugging Face 사례. 보안 연구팀이 Hugging Face에서 역직렬화 취약점이 포함된 악성 모델 100개 이상을 확인했습니다. 다운로드하는 즉시 임의 코드가 실행됩니다.</a:t>
-            </a:r>
-          </a:p>
+          <a:p/>
           <a:p>
             <a:endParaRPr/>
           </a:p>
-          <a:p>
-            <a:r>
-              <a:t>T03 백도어와의 차이: 삽입 위치가 '공장'이 아니라 '공개 저장소'입니다.</a:t>
-            </a:r>
-          </a:p>
-          <a:p>
-            <a:r>
-              <a:t>T14에서 T03으로, 다시 T08로 이어지는 연계 — 도입 전 검증이 유일한 방어선입니다.</a:t>
-            </a:r>
-          </a:p>
+          <a:p/>
+          <a:p/>
         </p:txBody>
       </p:sp>
       <p:sp>
@@ -4575,40 +3911,20 @@
         <p:txBody>
           <a:bodyPr/>
           <a:lstStyle/>
-          <a:p>
-            <a:r>
-              <a:t>[심화 슬라이드 — 시간 조율 시 생략 가능]</a:t>
-            </a:r>
-          </a:p>
+          <a:p/>
           <a:p>
             <a:endParaRPr/>
           </a:p>
-          <a:p>
-            <a:r>
-              <a:t>모델 직렬화에서 Pickle 포맷의 위험성입니다.</a:t>
-            </a:r>
-          </a:p>
-          <a:p>
-            <a:r>
-              <a:t>Pickle은 파이썬 객체를 파일로 저장하는 포맷인데, 역직렬화할 때 __reduce__ 메서드에 삽입된 임의 코드가 실행될 수 있습니다.</a:t>
-            </a:r>
-          </a:p>
+          <a:p/>
+          <a:p/>
           <a:p>
             <a:endParaRPr/>
           </a:p>
-          <a:p>
-            <a:r>
-              <a:t>대안: SafeTensors는 가중치만 저장하고 코드 실행이 불가능합니다. 권장 포맷입니다.</a:t>
-            </a:r>
-          </a:p>
+          <a:p/>
           <a:p>
             <a:endParaRPr/>
           </a:p>
-          <a:p>
-            <a:r>
-              <a:t>실무 팁: torch.load() 할 때 출처가 불확실한 .pkl 파일은 절대 로드하지 마십시오.</a:t>
-            </a:r>
-          </a:p>
+          <a:p/>
         </p:txBody>
       </p:sp>
       <p:sp>
@@ -4690,47 +4006,19 @@
         <p:txBody>
           <a:bodyPr/>
           <a:lstStyle/>
-          <a:p>
-            <a:r>
-              <a:t>T15 용역업체 보안관리 부실입니다.</a:t>
-            </a:r>
-          </a:p>
+          <a:p/>
           <a:p>
             <a:endParaRPr/>
           </a:p>
-          <a:p>
-            <a:r>
-              <a:t>세 가지 취약점:</a:t>
-            </a:r>
-          </a:p>
-          <a:p>
-            <a:r>
-              <a:t>개발 용역업체 직원이 프로덕션 DB에 직접 접근.</a:t>
-            </a:r>
-          </a:p>
-          <a:p>
-            <a:r>
-              <a:t>유지보수 원격 접속 계정이 계약 종료 후에도 활성 유지.</a:t>
-            </a:r>
-          </a:p>
-          <a:p>
-            <a:r>
-              <a:t>Meta EU 사례처럼 클라우드 벤더를 통한 데이터 국외 이전.</a:t>
-            </a:r>
-          </a:p>
+          <a:p/>
+          <a:p/>
+          <a:p/>
+          <a:p/>
           <a:p>
             <a:endParaRPr/>
           </a:p>
-          <a:p>
-            <a:r>
-              <a:t>대책: M27 보안계약 명시, 접근 권한 최소화, 계약 종료 즉시 회수.</a:t>
-            </a:r>
-          </a:p>
-          <a:p>
-            <a:r>
-              <a:t>간단하지만 조직 차원에서 가장 빈번하게 발생하는 유형입니다.</a:t>
-            </a:r>
-          </a:p>
+          <a:p/>
+          <a:p/>
         </p:txBody>
       </p:sp>
       <p:sp>
@@ -4812,45 +4100,21 @@
         <p:txBody>
           <a:bodyPr/>
           <a:lstStyle/>
-          <a:p>
-            <a:r>
-              <a:t>[정리 슬라이드] 위협은 홀로 작동하지 않습니다.</a:t>
-            </a:r>
-          </a:p>
+          <a:p/>
           <a:p>
             <a:endParaRPr/>
           </a:p>
-          <a:p>
-            <a:r>
-              <a:t>연계 사슬 1: T14 공급망 오염 → T03 백도어 → T06 모델 추출 → T09 적대적 예제.</a:t>
-            </a:r>
-          </a:p>
-          <a:p>
-            <a:r>
-              <a:t>연계 사슬 2: T01 RAG 오염 → T08 인젝션 → T13 권한 오남용.</a:t>
-            </a:r>
-          </a:p>
-          <a:p>
-            <a:r>
-              <a:t>연계 사슬 3: T02 비인가 학습 → T06 모델 추출 → T07 민감정보 유출.</a:t>
-            </a:r>
-          </a:p>
+          <a:p/>
+          <a:p/>
+          <a:p/>
           <a:p>
             <a:endParaRPr/>
           </a:p>
-          <a:p>
-            <a:r>
-              <a:t>그리고 T12 모니터링 부재는 모든 체인에서 탐지를 막습니다. T12 없이는 어떤 연계도 발견할 수 없습니다.</a:t>
-            </a:r>
-          </a:p>
+          <a:p/>
           <a:p>
             <a:endParaRPr/>
           </a:p>
-          <a:p>
-            <a:r>
-              <a:t>이 연계 관계를 이해하는 것이 1강의 핵심 목표였습니다.</a:t>
-            </a:r>
-          </a:p>
+          <a:p/>
         </p:txBody>
       </p:sp>
       <p:sp>
@@ -4932,42 +4196,18 @@
         <p:txBody>
           <a:bodyPr/>
           <a:lstStyle/>
-          <a:p>
-            <a:r>
-              <a:t>1강 정리입니다. 4줄로 요약합니다.</a:t>
-            </a:r>
-          </a:p>
+          <a:p/>
           <a:p>
             <a:endParaRPr/>
           </a:p>
-          <a:p>
-            <a:r>
-              <a:t>하나, 생성형 AI 공격 표면은 5개 지점: 입력 UI, LLM 엔진, RAG, 도구, 학습 데이터.</a:t>
-            </a:r>
-          </a:p>
-          <a:p>
-            <a:r>
-              <a:t>둘, 국정원 T01~T15는 4개 레이어: 입력조작, 데이터모델, 인프라, 공급망.</a:t>
-            </a:r>
-          </a:p>
-          <a:p>
-            <a:r>
-              <a:t>셋, T07과 T08이 지금 당장 위험한 위협. 사용자 의도와 무관하게 발생합니다.</a:t>
-            </a:r>
-          </a:p>
-          <a:p>
-            <a:r>
-              <a:t>넷, T12 모니터링 부재가 없으면 나머지 14개 위협이 발생해도 알 수 없습니다.</a:t>
-            </a:r>
-          </a:p>
+          <a:p/>
+          <a:p/>
+          <a:p/>
+          <a:p/>
           <a:p>
             <a:endParaRPr/>
           </a:p>
-          <a:p>
-            <a:r>
-              <a:t>이 네 가지를 기억하시면 오늘 하루 강의의 뼈대가 됩니다.</a:t>
-            </a:r>
-          </a:p>
+          <a:p/>
         </p:txBody>
       </p:sp>
       <p:sp>
@@ -5102,32 +4342,16 @@
             <a:noAutofit/>
           </a:bodyPr>
           <a:lstStyle/>
-          <a:p>
-            <a:r>
-              <a:t>[잠시 멈추고]</a:t>
-            </a:r>
-          </a:p>
+          <a:p/>
           <a:p>
             <a:endParaRPr/>
           </a:p>
-          <a:p>
-            <a:r>
-              <a:t>보안이 없으면, AI도 없습니다.</a:t>
-            </a:r>
-          </a:p>
+          <a:p/>
           <a:p>
             <a:endParaRPr/>
           </a:p>
-          <a:p>
-            <a:r>
-              <a:t>다음은 실습 1입니다. 방금 배운 T07, T08, T09를 직접 체험합니다. 공격자 관점에서 Gemini API를 실제로 공격해 봅니다.</a:t>
-            </a:r>
-          </a:p>
-          <a:p>
-            <a:r>
-              <a:t>10분 쉬고 실습으로 넘어가겠습니다.</a:t>
-            </a:r>
-          </a:p>
+          <a:p/>
+          <a:p/>
         </p:txBody>
       </p:sp>
     </p:spTree>
@@ -5181,37 +4405,17 @@
         <p:txBody>
           <a:bodyPr/>
           <a:lstStyle/>
-          <a:p>
-            <a:r>
-              <a:t>1강을 마치면 이 세 가지를 할 수 있어야 합니다.</a:t>
-            </a:r>
-          </a:p>
+          <a:p/>
           <a:p>
             <a:endParaRPr/>
           </a:p>
-          <a:p>
-            <a:r>
-              <a:t>첫째, LLM·RAG·Agent 각각의 공격 표면이 어디인지 설명할 수 있다.</a:t>
-            </a:r>
-          </a:p>
-          <a:p>
-            <a:r>
-              <a:t>둘째, NIS T01~T15를 4개 레이어로 구분하고 각 레이어의 핵심 원리를 말할 수 있다.</a:t>
-            </a:r>
-          </a:p>
-          <a:p>
-            <a:r>
-              <a:t>셋째, 위협이 단독이 아니라 연계된다는 것 — T06에서 T09로, T14에서 T03을 거쳐 T08로 이어지는 체인을 이해한다.</a:t>
-            </a:r>
-          </a:p>
+          <a:p/>
+          <a:p/>
+          <a:p/>
           <a:p>
             <a:endParaRPr/>
           </a:p>
-          <a:p>
-            <a:r>
-              <a:t>특히 세 번째가 중요합니다. 위협을 개별적으로만 보면 방어 설계가 틀어집니다.</a:t>
-            </a:r>
-          </a:p>
+          <a:p/>
         </p:txBody>
       </p:sp>
       <p:sp>
@@ -5293,19 +4497,11 @@
         <p:txBody>
           <a:bodyPr/>
           <a:lstStyle/>
-          <a:p>
-            <a:r>
-              <a:t>AI 보안 이야기를 시작하기 전에, '데이터로 할 수 있는 일'이 어디까지인지 실제 사례 두 가지를 먼저 보겠습니다.</a:t>
-            </a:r>
-          </a:p>
+          <a:p/>
           <a:p>
             <a:endParaRPr/>
           </a:p>
-          <a:p>
-            <a:r>
-              <a:t>이 사례들이 왜 AI 보안과 연결되는지는 사례를 본 뒤에 정리합니다.</a:t>
-            </a:r>
-          </a:p>
+          <a:p/>
         </p:txBody>
       </p:sp>
       <p:sp>
@@ -5387,40 +4583,20 @@
         <p:txBody>
           <a:bodyPr/>
           <a:lstStyle/>
-          <a:p>
-            <a:r>
-              <a:t>[잠시 멈추고] 여러분이 10년 전 올린 SNS 사진 한 장. 그 사진이 지금 이 순간 누군가를 특정하는 데 쓰이고 있을 수 있습니다.</a:t>
-            </a:r>
-          </a:p>
+          <a:p/>
           <a:p>
             <a:endParaRPr/>
           </a:p>
-          <a:p>
-            <a:r>
-              <a:t>Clearview AI는 SNS, 뉴스, 공공 기록에서 30억 장 이상의 얼굴 사진을 무단 수집해서 미국, 캐나다, 호주의 3,100개 이상 법집행기관에 납품했습니다.</a:t>
-            </a:r>
-          </a:p>
-          <a:p>
-            <a:r>
-              <a:t>현장 사진 1장만 올리면 수초 내에 이름, 주소, SNS 계정이 나옵니다.</a:t>
-            </a:r>
-          </a:p>
+          <a:p/>
+          <a:p/>
           <a:p>
             <a:endParaRPr/>
           </a:p>
-          <a:p>
-            <a:r>
-              <a:t>EU GDPR 위반 과징금, 캐나다·호주에서 사용 금지 판결이 났지만 — 이미 구축된 DB는 존재합니다.</a:t>
-            </a:r>
-          </a:p>
+          <a:p/>
           <a:p>
             <a:endParaRPr/>
           </a:p>
-          <a:p>
-            <a:r>
-              <a:t>핵심은: 공개된 데이터를 AI가 모으면 비공개 정보가 됩니다. 이것이 T07의 근본 원리입니다.</a:t>
-            </a:r>
-          </a:p>
+          <a:p/>
         </p:txBody>
       </p:sp>
       <p:sp>
@@ -5502,35 +4678,19 @@
         <p:txBody>
           <a:bodyPr/>
           <a:lstStyle/>
-          <a:p>
-            <a:r>
-              <a:t>두 번째 사례입니다. 더 충격적일 수 있습니다.</a:t>
-            </a:r>
-          </a:p>
+          <a:p/>
           <a:p>
             <a:endParaRPr/>
           </a:p>
-          <a:p>
-            <a:r>
-              <a:t>Parabon NanoLabs는 범죄 현장의 DNA만으로 용의자의 피부색, 눈색, 얼굴형을 AI로 예측합니다. 실제 수사에서 몽타주로 사용되고 있습니다.</a:t>
-            </a:r>
-          </a:p>
+          <a:p/>
           <a:p>
             <a:endParaRPr/>
           </a:p>
-          <a:p>
-            <a:r>
-              <a:t>Harvard Medical School 연구에서는 익명화된 의료 유전체 데이터를 공개 DB와 교차 분석해서 익명화를 해제하고 개인을 식별했습니다.</a:t>
-            </a:r>
-          </a:p>
+          <a:p/>
           <a:p>
             <a:endParaRPr/>
           </a:p>
-          <a:p>
-            <a:r>
-              <a:t>메시지는 명확합니다: 익명화했다고 안전한 게 아닙니다. AI는 '다른 데이터'와 연결해서 다시 특정합니다. 이것이 T02, T04와 연결됩니다.</a:t>
-            </a:r>
-          </a:p>
+          <a:p/>
         </p:txBody>
       </p:sp>
       <p:sp>
@@ -5612,37 +4772,17 @@
         <p:txBody>
           <a:bodyPr/>
           <a:lstStyle/>
-          <a:p>
-            <a:r>
-              <a:t>두 사례의 공통 원리를 정리합니다.</a:t>
-            </a:r>
-          </a:p>
+          <a:p/>
           <a:p>
             <a:endParaRPr/>
           </a:p>
-          <a:p>
-            <a:r>
-              <a:t>공개된 조각 A와 공개된 조각 B를 AI가 추론으로 결합하면 비공개 민감정보가 됩니다.</a:t>
-            </a:r>
-          </a:p>
-          <a:p>
-            <a:r>
-              <a:t>여기서 AI가 기존 방식과 다른 점 세 가지: 속도가 수일에서 수초로, 규모가 1명에서 수백만 명 동시로, 정확도가 추론 오류 급감.</a:t>
-            </a:r>
-          </a:p>
+          <a:p/>
+          <a:p/>
           <a:p>
             <a:endParaRPr/>
           </a:p>
-          <a:p>
-            <a:r>
-              <a:t>이것이 T07 민감정보 유출과 T08 프롬프트 인젝션의 근본 원인입니다.</a:t>
-            </a:r>
-          </a:p>
-          <a:p>
-            <a:r>
-              <a:t>기술이 아니라 구조의 문제라는 점을 기억해 주십시오.</a:t>
-            </a:r>
-          </a:p>
+          <a:p/>
+          <a:p/>
         </p:txBody>
       </p:sp>
       <p:sp>

</xml_diff>